<commit_message>
Apresentação de umidade: linguagem gerencial e sem dados de aderência
Retira os testes estatísticos e a nota técnica da carta de controle,
nomeia as linhas de referência no próprio gráfico e remove do slide 3 os
dados de aderência da planilha de limpezas.

Co-Authored-By: Claude Opus 5.5 <noreply@anthropic.com>
Claude-Session: https://claude.ai/code/session_013vrRRygeVyoFrmpESXw7PA
</commit_message>
<xml_diff>
--- a/apresentacoes/Umidade_Filtro_Prensa_Limpeza.pptx
+++ b/apresentacoes/Umidade_Filtro_Prensa_Limpeza.pptx
@@ -109,17 +109,17 @@
   <p:extLst>
     <p:ext uri="{521415D9-36F7-43E2-AB2F-B90AF26B5E84}">
       <p14:sectionLst xmlns:p14="http://schemas.microsoft.com/office/powerpoint/2010/main">
-        <p14:section name="Resultado" id="{7b4dd969-40b7-a251-1666-e93b28633236}">
+        <p14:section name="Resultado" id="{50949e52-807e-1ef4-8566-4f69b6298050}">
           <p14:sldIdLst>
             <p14:sldId id="256"/>
           </p14:sldIdLst>
         </p14:section>
-        <p14:section name="Evidência estatística" id="{073555ff-e59a-71c3-ed1c-6bbb01941d36}">
+        <p14:section name="Evidência estatística" id="{e9178527-0480-50fb-033c-c24d6cd299d7}">
           <p14:sldIdLst>
             <p14:sldId id="257"/>
           </p14:sldIdLst>
         </p14:section>
-        <p14:section name="Ações e próximos passos" id="{52b18df9-252c-0735-d3cc-eec13776c03a}">
+        <p14:section name="Rota de limpeza" id="{c12dd906-fc0b-7f02-eb46-ea2c2a511738}">
           <p14:sldIdLst>
             <p14:sldId id="258"/>
           </p14:sldIdLst>
@@ -580,10 +580,10 @@
           <c:layoutTarget val="inner"/>
           <c:xMode val="edge"/>
           <c:yMode val="edge"/>
-          <c:x val="0.08"/>
-          <c:y val="0.1"/>
-          <c:w val="0.9"/>
-          <c:h val="0.68"/>
+          <c:x val="0.07"/>
+          <c:y val="0.09"/>
+          <c:w val="0.76"/>
+          <c:h val="0.8"/>
         </c:manualLayout>
       </c:layout>
       <c:lineChart>
@@ -792,7 +792,7 @@
               <c:strCache>
                 <c:ptCount val="1"/>
                 <c:pt idx="0">
-                  <c:v>LC 17,15</c:v>
+                  <c:v>Média antes</c:v>
                 </c:pt>
               </c:strCache>
             </c:strRef>
@@ -985,7 +985,7 @@
               <c:strCache>
                 <c:ptCount val="1"/>
                 <c:pt idx="0">
-                  <c:v>LSC 17,60</c:v>
+                  <c:v>Limite superior</c:v>
                 </c:pt>
               </c:strCache>
             </c:strRef>
@@ -1147,7 +1147,7 @@
               <c:strCache>
                 <c:ptCount val="1"/>
                 <c:pt idx="0">
-                  <c:v>LIC 16,70</c:v>
+                  <c:v>Limite inferior</c:v>
                 </c:pt>
               </c:strCache>
             </c:strRef>
@@ -1429,26 +1429,6 @@
         <a:effectLst/>
       </c:spPr>
     </c:plotArea>
-    <c:legend>
-      <c:legendPos val="b"/>
-      <c:overlay val="0"/>
-      <c:txPr>
-        <a:bodyPr/>
-        <a:lstStyle/>
-        <a:p>
-          <a:pPr>
-            <a:defRPr sz="1100">
-              <a:solidFill>
-                <a:srgbClr val="1D2B36"/>
-              </a:solidFill>
-              <a:latin typeface="+mn-lt"/>
-              <a:cs typeface="+mn-lt"/>
-            </a:defRPr>
-          </a:pPr>
-          <a:endParaRPr lang="en-US"/>
-        </a:p>
-      </c:txPr>
-    </c:legend>
     <c:plotVisOnly val="1"/>
     <c:dispBlanksAs val="span"/>
   </c:chart>
@@ -1951,10 +1931,9 @@
           <a:p>
             <a:r>
               <a:rPr lang="en-US" dirty="0"/>
-              <a:t>Carta de controle: a linha central (LC = 17,15%) e os limites (LSC = 17,60%, LIC = 16,70%) foram calculados apenas com o período sem rotina (nov/25–mai/26, 204 dias). O desvio de curto prazo foi estimado pela amplitude móvel média (MR/1,128 = 0,82 pp) e os limites das médias mensais usam n ≈ 30 dias (3σ/√30 = 0,45 pp).
-Leitura: antes da rotina o processo subia (mar/26 chegou a 17,64%, acima do LSC). Depois de jun/26 todos os 5 meses ficaram abaixo da LC; jul (16,63), set (16,17) e out (15,40) abaixo do LIC. Pelas regras de Western Electric, '4 de 5 pontos além de 1σ' e '2 de 3 além de 2σ' indicam mudança real de patamar — não é variação aleatória.
-Testes de hipótese com as médias mensais (H1: umidade com rotina &lt; umidade sem rotina): Mann-Whitney unilateral p = 0,024 (significativo a 95%); t de Welch p = 0,056. Usando como base só jan–mai/26 (após a partida dos filtros): Mann-Whitney p = 0,004 e Welch p = 0,026.
-Dados diários (nov/25 a 08/07/26): antes 204 dias, média 17,15%, desvio 0,97; jun–08/jul 38 dias, média 16,88%. Mann-Whitney unilateral p = 0,028. Observação: o arquivo .xls exportado só traz até 08/07/26 (limite de 256 colunas do formato), por isso a comparação mensal usa os valores do MES para jul–out.</a:t>
+              <a:t>Como ler: a linha cinza é a média dos meses sem rotina (17,15%). As linhas laranja tracejadas são os limites de controle: enquanto o processo está no mesmo patamar, as médias mensais oscilam entre elas. Antes da rotina o processo chegou a passar do limite superior (mar/26, 17,64%). Depois de jun/26 todos os meses ficaram abaixo da média, e julho (16,63%), setembro (16,17%) e outubro (15,40%) abaixo do limite inferior — sinal de que o patamar do processo mudou.
+Se perguntarem como foi calculado: os limites usam a variação dia a dia do período nov/25–mai/26 (amplitude móvel; σ = 0,82 pp) para médias de ~30 dias: 17,15 ± 0,45. Teste de Mann-Whitney entre as médias mensais antes e depois: p = 0,024 (significativo a 95%).
+Fonte: MES Samarco – PF Elutriação H₂O, média aritmética mensal; out/26 parcial (1 a 22/10).</a:t>
             </a:r>
             <a:endParaRPr lang="en-US" dirty="0"/>
           </a:p>
@@ -2042,10 +2021,9 @@
           <a:p>
             <a:r>
               <a:rPr lang="en-US" dirty="0"/>
-              <a:t>O que foi feito: rota semanal fixa (SEG FP001, TER FP002, QUA FP005, QUI FP003, SEX FP004); a limpeza é responsabilidade da letra que está no turno 1 (07–19h) no dia, conforme a escala de revezamento 2026–2030; o cumprimento é acompanhado mensalmente no painel HTML de gestão da limpeza (previstas × realizadas, aderência por letra e ranking de operadores).
-Mecanismo: a colmatação do tecido filtrante reduz a permeabilidade e a eficiência do sopro/drenagem, aumentando a umidade residual da torta. Na partida (nov–dez/25), com tecidos novos, a umidade era 16,57–16,75%; sem limpeza sistemática ela subiu até 17,64% (mar/26). Com a rotina, a umidade caiu abaixo inclusive da condição de tecido novo.
-Oportunidade: o ganho foi obtido mesmo com aderência parcial à rota (setembro 41%, outubro 67% até 22/10). Atingir ≥ 90% tende a consolidar e ampliar o resultado.
-Cuidados na interpretação: em 01/08/26 foi feita a troca geral de 31 tecidos do FP001, que também reduz a umidade; outubro é parcial; outras variáveis de processo não foram controladas. Recomenda-se repetir a análise ao fechar out/26 e nov/26.</a:t>
+              <a:t>O que foi implantado: rota semanal fixa (SEG FP001, TER FP002, QUA FP005, QUI FP003, SEX FP004), com a limpeza feita pela turma do turno do dia, conforme a escala de revezamento. Assim, cada um dos 5 filtros é limpo uma vez por semana.
+Por que funciona: a colmatação do tecido filtrante reduz a drenagem e aumenta a água retida na torta. Na partida (nov–dez/25), com tecidos novos, a umidade era 16,57–16,75%; sem limpeza sistemática subiu até 17,64% (mar/26). Com a rotina, caiu abaixo da condição de tecido novo (15,40% em out/26).
+Próximos passos: manter a rota como padrão operacional, acompanhar a umidade mês a mês para confirmar o novo patamar e calcular o ganho energético a partir da redução de água na torta.</a:t>
             </a:r>
             <a:endParaRPr lang="en-US" dirty="0"/>
           </a:p>
@@ -2999,7 +2977,7 @@
                   <a:schemeClr val="bg1"/>
                 </a:solidFill>
               </a:rPr>
-              <a:t>redução relativa da umidade da torta</a:t>
+              <a:t>de redução em relação à umidade anterior</a:t>
             </a:r>
             <a:endParaRPr lang="en-US" sz="1200" dirty="0"/>
           </a:p>
@@ -3098,7 +3076,7 @@
                   <a:schemeClr val="bg1"/>
                 </a:solidFill>
               </a:rPr>
-              <a:t>de água por tonelada de sólido seco (−12%)</a:t>
+              <a:t>de água em cada tonelada de concentrado seco</a:t>
             </a:r>
             <a:endParaRPr lang="en-US" sz="1200" dirty="0"/>
           </a:p>
@@ -3465,15 +3443,51 @@
           </a:p>
         </p:txBody>
       </p:sp>
+      <p:sp>
+        <p:nvSpPr>
+          <p:cNvPr id="3" name="Título carta"/>
+          <p:cNvSpPr txBox="1"/>
+          <p:nvPr/>
+        </p:nvSpPr>
+        <p:spPr>
+          <a:xfrm>
+            <a:off x="548640" y="1280160"/>
+            <a:ext cx="4114800" cy="274320"/>
+          </a:xfrm>
+          <a:prstGeom prst="rect">
+            <a:avLst/>
+          </a:prstGeom>
+          <a:noFill/>
+          <a:ln/>
+        </p:spPr>
+        <p:txBody>
+          <a:bodyPr wrap="square" lIns="0" tIns="0" rIns="0" bIns="0" rtlCol="0" anchor="ctr"/>
+          <a:lstStyle/>
+          <a:p>
+            <a:pPr indent="0" marL="0">
+              <a:buNone/>
+            </a:pPr>
+            <a:r>
+              <a:rPr lang="en-US" sz="1300" b="1" dirty="0">
+                <a:solidFill>
+                  <a:schemeClr val="tx2"/>
+                </a:solidFill>
+              </a:rPr>
+              <a:t>Umidade H₂O – média mensal (%)</a:t>
+            </a:r>
+            <a:endParaRPr lang="en-US" sz="1300" dirty="0"/>
+          </a:p>
+        </p:txBody>
+      </p:sp>
       <p:graphicFrame>
         <p:nvGraphicFramePr>
-          <p:cNvPr id="3" name="Carta de controle" descr=""/>
+          <p:cNvPr id="4" name="Carta de controle" descr=""/>
           <p:cNvGraphicFramePr/>
           <p:nvPr/>
         </p:nvGraphicFramePr>
         <p:xfrm>
           <a:off x="411480" y="1417320"/>
-          <a:ext cx="7178040" cy="4434840"/>
+          <a:ext cx="7726680" cy="4572000"/>
         </p:xfrm>
         <a:graphic xmlns:a="http://schemas.openxmlformats.org/drawingml/2006/main">
           <a:graphicData uri="http://schemas.openxmlformats.org/drawingml/2006/chart">
@@ -3483,14 +3497,14 @@
       </p:graphicFrame>
       <p:sp>
         <p:nvSpPr>
-          <p:cNvPr id="4" name="Marco início da rotina"/>
+          <p:cNvPr id="5" name="Marco início da rotina"/>
           <p:cNvSpPr/>
           <p:nvPr/>
         </p:nvSpPr>
         <p:spPr>
           <a:xfrm>
-            <a:off x="4754194" y="1723644"/>
-            <a:ext cx="0" cy="3152851"/>
+            <a:off x="4377842" y="1737360"/>
+            <a:ext cx="0" cy="3749040"/>
           </a:xfrm>
           <a:prstGeom prst="line">
             <a:avLst/>
@@ -3506,13 +3520,13 @@
       </p:sp>
       <p:sp>
         <p:nvSpPr>
-          <p:cNvPr id="5" name="Rótulo marco"/>
+          <p:cNvPr id="6" name="Rótulo marco"/>
           <p:cNvSpPr txBox="1"/>
           <p:nvPr/>
         </p:nvSpPr>
         <p:spPr>
           <a:xfrm>
-            <a:off x="4827346" y="1677924"/>
+            <a:off x="4450994" y="1719072"/>
             <a:ext cx="2377440" cy="228600"/>
           </a:xfrm>
           <a:prstGeom prst="rect">
@@ -3542,14 +3556,14 @@
       </p:sp>
       <p:sp>
         <p:nvSpPr>
-          <p:cNvPr id="6" name="Título carta"/>
+          <p:cNvPr id="7" name="Rótulo Limite superior"/>
           <p:cNvSpPr txBox="1"/>
           <p:nvPr/>
         </p:nvSpPr>
         <p:spPr>
           <a:xfrm>
-            <a:off x="548640" y="1280160"/>
-            <a:ext cx="4114800" cy="274320"/>
+            <a:off x="6934352" y="2115312"/>
+            <a:ext cx="1188720" cy="402336"/>
           </a:xfrm>
           <a:prstGeom prst="rect">
             <a:avLst/>
@@ -3565,14 +3579,128 @@
               <a:buNone/>
             </a:pPr>
             <a:r>
-              <a:rPr lang="en-US" sz="1300" b="1" dirty="0">
-                <a:solidFill>
-                  <a:schemeClr val="tx2"/>
+              <a:rPr lang="en-US" sz="1100" dirty="0">
+                <a:solidFill>
+                  <a:schemeClr val="accent4"/>
                 </a:solidFill>
               </a:rPr>
-              <a:t>Carta de controle das médias mensais</a:t>
-            </a:r>
-            <a:endParaRPr lang="en-US" sz="1300" dirty="0"/>
+              <a:t>Limite superior</a:t>
+            </a:r>
+            <a:endParaRPr lang="en-US" sz="1100" dirty="0"/>
+          </a:p>
+          <a:p>
+            <a:pPr indent="0" marL="0">
+              <a:buNone/>
+            </a:pPr>
+            <a:r>
+              <a:rPr lang="en-US" sz="1100" b="1" dirty="0">
+                <a:solidFill>
+                  <a:schemeClr val="accent4"/>
+                </a:solidFill>
+              </a:rPr>
+              <a:t>17,60%</a:t>
+            </a:r>
+            <a:endParaRPr lang="en-US" sz="1100" dirty="0"/>
+          </a:p>
+        </p:txBody>
+      </p:sp>
+      <p:sp>
+        <p:nvSpPr>
+          <p:cNvPr id="8" name="Rótulo Média antes"/>
+          <p:cNvSpPr txBox="1"/>
+          <p:nvPr/>
+        </p:nvSpPr>
+        <p:spPr>
+          <a:xfrm>
+            <a:off x="6934352" y="2663952"/>
+            <a:ext cx="1188720" cy="402336"/>
+          </a:xfrm>
+          <a:prstGeom prst="rect">
+            <a:avLst/>
+          </a:prstGeom>
+          <a:noFill/>
+          <a:ln/>
+        </p:spPr>
+        <p:txBody>
+          <a:bodyPr wrap="square" lIns="0" tIns="0" rIns="0" bIns="0" rtlCol="0" anchor="ctr"/>
+          <a:lstStyle/>
+          <a:p>
+            <a:pPr indent="0" marL="0">
+              <a:buNone/>
+            </a:pPr>
+            <a:r>
+              <a:rPr lang="en-US" sz="1100" dirty="0">
+                <a:solidFill>
+                  <a:schemeClr val="accent5"/>
+                </a:solidFill>
+              </a:rPr>
+              <a:t>Média antes</a:t>
+            </a:r>
+            <a:endParaRPr lang="en-US" sz="1100" dirty="0"/>
+          </a:p>
+          <a:p>
+            <a:pPr indent="0" marL="0">
+              <a:buNone/>
+            </a:pPr>
+            <a:r>
+              <a:rPr lang="en-US" sz="1100" b="1" dirty="0">
+                <a:solidFill>
+                  <a:schemeClr val="accent5"/>
+                </a:solidFill>
+              </a:rPr>
+              <a:t>17,15%</a:t>
+            </a:r>
+            <a:endParaRPr lang="en-US" sz="1100" dirty="0"/>
+          </a:p>
+        </p:txBody>
+      </p:sp>
+      <p:sp>
+        <p:nvSpPr>
+          <p:cNvPr id="9" name="Rótulo Limite inferior"/>
+          <p:cNvSpPr txBox="1"/>
+          <p:nvPr/>
+        </p:nvSpPr>
+        <p:spPr>
+          <a:xfrm>
+            <a:off x="6934352" y="3212592"/>
+            <a:ext cx="1188720" cy="402336"/>
+          </a:xfrm>
+          <a:prstGeom prst="rect">
+            <a:avLst/>
+          </a:prstGeom>
+          <a:noFill/>
+          <a:ln/>
+        </p:spPr>
+        <p:txBody>
+          <a:bodyPr wrap="square" lIns="0" tIns="0" rIns="0" bIns="0" rtlCol="0" anchor="ctr"/>
+          <a:lstStyle/>
+          <a:p>
+            <a:pPr indent="0" marL="0">
+              <a:buNone/>
+            </a:pPr>
+            <a:r>
+              <a:rPr lang="en-US" sz="1100" dirty="0">
+                <a:solidFill>
+                  <a:schemeClr val="accent4"/>
+                </a:solidFill>
+              </a:rPr>
+              <a:t>Limite inferior</a:t>
+            </a:r>
+            <a:endParaRPr lang="en-US" sz="1100" dirty="0"/>
+          </a:p>
+          <a:p>
+            <a:pPr indent="0" marL="0">
+              <a:buNone/>
+            </a:pPr>
+            <a:r>
+              <a:rPr lang="en-US" sz="1100" b="1" dirty="0">
+                <a:solidFill>
+                  <a:schemeClr val="accent4"/>
+                </a:solidFill>
+              </a:rPr>
+              <a:t>16,70%</a:t>
+            </a:r>
+            <a:endParaRPr lang="en-US" sz="1100" dirty="0"/>
           </a:p>
         </p:txBody>
       </p:sp>
@@ -3591,19 +3719,19 @@
           </p:nvPr>
         </p:nvGraphicFramePr>
         <p:xfrm>
-          <a:off x="7863840" y="1417320"/>
-          <a:ext cx="3776472" cy="914400"/>
+          <a:off x="8366760" y="1417320"/>
+          <a:ext cx="3273552" cy="914400"/>
         </p:xfrm>
         <a:graphic>
           <a:graphicData uri="http://schemas.openxmlformats.org/drawingml/2006/table">
             <a:tbl>
               <a:tblPr/>
               <a:tblGrid>
-                <a:gridCol w="1216152"/>
-                <a:gridCol w="1280160"/>
-                <a:gridCol w="1280160"/>
+                <a:gridCol w="1005840"/>
+                <a:gridCol w="1133856"/>
+                <a:gridCol w="1133856"/>
               </a:tblGrid>
-              <a:tr h="457200">
+              <a:tr h="502920">
                 <a:tc>
                   <a:txBody>
                     <a:bodyPr/>
@@ -3808,192 +3936,7 @@
                   </a:tcPr>
                 </a:tc>
               </a:tr>
-              <a:tr h="292608">
-                <a:tc>
-                  <a:txBody>
-                    <a:bodyPr/>
-                    <a:lstStyle/>
-                    <a:p>
-                      <a:pPr indent="0" marL="0">
-                        <a:buNone/>
-                      </a:pPr>
-                      <a:r>
-                        <a:rPr lang="en-US" sz="1200" b="1" dirty="0">
-                          <a:solidFill>
-                            <a:schemeClr val="tx1"/>
-                          </a:solidFill>
-                        </a:rPr>
-                        <a:t>Meses</a:t>
-                      </a:r>
-                      <a:endParaRPr lang="en-US" sz="1200" dirty="0"/>
-                    </a:p>
-                  </a:txBody>
-                  <a:tcPr marL="54864" marR="54864" marT="27432" marB="27432" anchor="ctr">
-                    <a:lnL w="6350" cap="flat" cmpd="sng" algn="ctr">
-                      <a:solidFill>
-                        <a:srgbClr val="DDE3E8"/>
-                      </a:solidFill>
-                      <a:prstDash val="solid"/>
-                      <a:round/>
-                      <a:headEnd type="none" w="med" len="med"/>
-                      <a:tailEnd type="none" w="med" len="med"/>
-                    </a:lnL>
-                    <a:lnR w="6350" cap="flat" cmpd="sng" algn="ctr">
-                      <a:solidFill>
-                        <a:srgbClr val="DDE3E8"/>
-                      </a:solidFill>
-                      <a:prstDash val="solid"/>
-                      <a:round/>
-                      <a:headEnd type="none" w="med" len="med"/>
-                      <a:tailEnd type="none" w="med" len="med"/>
-                    </a:lnR>
-                    <a:lnT w="6350" cap="flat" cmpd="sng" algn="ctr">
-                      <a:solidFill>
-                        <a:srgbClr val="DDE3E8"/>
-                      </a:solidFill>
-                      <a:prstDash val="solid"/>
-                      <a:round/>
-                      <a:headEnd type="none" w="med" len="med"/>
-                      <a:tailEnd type="none" w="med" len="med"/>
-                    </a:lnT>
-                    <a:lnB w="6350" cap="flat" cmpd="sng" algn="ctr">
-                      <a:solidFill>
-                        <a:srgbClr val="DDE3E8"/>
-                      </a:solidFill>
-                      <a:prstDash val="solid"/>
-                      <a:round/>
-                      <a:headEnd type="none" w="med" len="med"/>
-                      <a:tailEnd type="none" w="med" len="med"/>
-                    </a:lnB>
-                    <a:solidFill>
-                      <a:schemeClr val="bg1"/>
-                    </a:solidFill>
-                  </a:tcPr>
-                </a:tc>
-                <a:tc>
-                  <a:txBody>
-                    <a:bodyPr/>
-                    <a:lstStyle/>
-                    <a:p>
-                      <a:pPr algn="ctr" indent="0" marL="0">
-                        <a:buNone/>
-                      </a:pPr>
-                      <a:r>
-                        <a:rPr lang="en-US" sz="1200" dirty="0">
-                          <a:solidFill>
-                            <a:schemeClr val="tx1"/>
-                          </a:solidFill>
-                        </a:rPr>
-                        <a:t>7</a:t>
-                      </a:r>
-                      <a:endParaRPr lang="en-US" sz="1200" dirty="0"/>
-                    </a:p>
-                  </a:txBody>
-                  <a:tcPr marL="54864" marR="54864" marT="27432" marB="27432" anchor="ctr">
-                    <a:lnL w="6350" cap="flat" cmpd="sng" algn="ctr">
-                      <a:solidFill>
-                        <a:srgbClr val="DDE3E8"/>
-                      </a:solidFill>
-                      <a:prstDash val="solid"/>
-                      <a:round/>
-                      <a:headEnd type="none" w="med" len="med"/>
-                      <a:tailEnd type="none" w="med" len="med"/>
-                    </a:lnL>
-                    <a:lnR w="6350" cap="flat" cmpd="sng" algn="ctr">
-                      <a:solidFill>
-                        <a:srgbClr val="DDE3E8"/>
-                      </a:solidFill>
-                      <a:prstDash val="solid"/>
-                      <a:round/>
-                      <a:headEnd type="none" w="med" len="med"/>
-                      <a:tailEnd type="none" w="med" len="med"/>
-                    </a:lnR>
-                    <a:lnT w="6350" cap="flat" cmpd="sng" algn="ctr">
-                      <a:solidFill>
-                        <a:srgbClr val="DDE3E8"/>
-                      </a:solidFill>
-                      <a:prstDash val="solid"/>
-                      <a:round/>
-                      <a:headEnd type="none" w="med" len="med"/>
-                      <a:tailEnd type="none" w="med" len="med"/>
-                    </a:lnT>
-                    <a:lnB w="6350" cap="flat" cmpd="sng" algn="ctr">
-                      <a:solidFill>
-                        <a:srgbClr val="DDE3E8"/>
-                      </a:solidFill>
-                      <a:prstDash val="solid"/>
-                      <a:round/>
-                      <a:headEnd type="none" w="med" len="med"/>
-                      <a:tailEnd type="none" w="med" len="med"/>
-                    </a:lnB>
-                    <a:solidFill>
-                      <a:schemeClr val="bg1"/>
-                    </a:solidFill>
-                  </a:tcPr>
-                </a:tc>
-                <a:tc>
-                  <a:txBody>
-                    <a:bodyPr/>
-                    <a:lstStyle/>
-                    <a:p>
-                      <a:pPr algn="ctr" indent="0" marL="0">
-                        <a:buNone/>
-                      </a:pPr>
-                      <a:r>
-                        <a:rPr lang="en-US" sz="1200" b="1" dirty="0">
-                          <a:solidFill>
-                            <a:schemeClr val="tx2"/>
-                          </a:solidFill>
-                        </a:rPr>
-                        <a:t>5</a:t>
-                      </a:r>
-                      <a:endParaRPr lang="en-US" sz="1200" dirty="0"/>
-                    </a:p>
-                  </a:txBody>
-                  <a:tcPr marL="54864" marR="54864" marT="27432" marB="27432" anchor="ctr">
-                    <a:lnL w="6350" cap="flat" cmpd="sng" algn="ctr">
-                      <a:solidFill>
-                        <a:srgbClr val="DDE3E8"/>
-                      </a:solidFill>
-                      <a:prstDash val="solid"/>
-                      <a:round/>
-                      <a:headEnd type="none" w="med" len="med"/>
-                      <a:tailEnd type="none" w="med" len="med"/>
-                    </a:lnL>
-                    <a:lnR w="6350" cap="flat" cmpd="sng" algn="ctr">
-                      <a:solidFill>
-                        <a:srgbClr val="DDE3E8"/>
-                      </a:solidFill>
-                      <a:prstDash val="solid"/>
-                      <a:round/>
-                      <a:headEnd type="none" w="med" len="med"/>
-                      <a:tailEnd type="none" w="med" len="med"/>
-                    </a:lnR>
-                    <a:lnT w="6350" cap="flat" cmpd="sng" algn="ctr">
-                      <a:solidFill>
-                        <a:srgbClr val="DDE3E8"/>
-                      </a:solidFill>
-                      <a:prstDash val="solid"/>
-                      <a:round/>
-                      <a:headEnd type="none" w="med" len="med"/>
-                      <a:tailEnd type="none" w="med" len="med"/>
-                    </a:lnT>
-                    <a:lnB w="6350" cap="flat" cmpd="sng" algn="ctr">
-                      <a:solidFill>
-                        <a:srgbClr val="DDE3E8"/>
-                      </a:solidFill>
-                      <a:prstDash val="solid"/>
-                      <a:round/>
-                      <a:headEnd type="none" w="med" len="med"/>
-                      <a:tailEnd type="none" w="med" len="med"/>
-                    </a:lnB>
-                    <a:solidFill>
-                      <a:schemeClr val="bg1"/>
-                    </a:solidFill>
-                  </a:tcPr>
-                </a:tc>
-              </a:tr>
-              <a:tr h="292608">
+              <a:tr h="347472">
                 <a:tc>
                   <a:txBody>
                     <a:bodyPr/>
@@ -4178,7 +4121,7 @@
                   </a:tcPr>
                 </a:tc>
               </a:tr>
-              <a:tr h="292608">
+              <a:tr h="347472">
                 <a:tc>
                   <a:txBody>
                     <a:bodyPr/>
@@ -4193,7 +4136,7 @@
                             <a:schemeClr val="tx1"/>
                           </a:solidFill>
                         </a:rPr>
-                        <a:t>Desvio-padrão</a:t>
+                        <a:t>Menor mês</a:t>
                       </a:r>
                       <a:endParaRPr lang="en-US" sz="1200" dirty="0"/>
                     </a:p>
@@ -4254,7 +4197,7 @@
                             <a:schemeClr val="tx1"/>
                           </a:solidFill>
                         </a:rPr>
-                        <a:t>0,39 pp</a:t>
+                        <a:t>16,57%</a:t>
                       </a:r>
                       <a:endParaRPr lang="en-US" sz="1200" dirty="0"/>
                     </a:p>
@@ -4315,7 +4258,7 @@
                             <a:schemeClr val="tx2"/>
                           </a:solidFill>
                         </a:rPr>
-                        <a:t>0,64 pp</a:t>
+                        <a:t>15,40%</a:t>
                       </a:r>
                       <a:endParaRPr lang="en-US" sz="1200" dirty="0"/>
                     </a:p>
@@ -4363,7 +4306,7 @@
                   </a:tcPr>
                 </a:tc>
               </a:tr>
-              <a:tr h="292608">
+              <a:tr h="347472">
                 <a:tc>
                   <a:txBody>
                     <a:bodyPr/>
@@ -4378,7 +4321,7 @@
                             <a:schemeClr val="tx1"/>
                           </a:solidFill>
                         </a:rPr>
-                        <a:t>Mín. – máx.</a:t>
+                        <a:t>Maior mês</a:t>
                       </a:r>
                       <a:endParaRPr lang="en-US" sz="1200" dirty="0"/>
                     </a:p>
@@ -4439,7 +4382,7 @@
                             <a:schemeClr val="tx1"/>
                           </a:solidFill>
                         </a:rPr>
-                        <a:t>16,57 – 17,64</a:t>
+                        <a:t>17,64%</a:t>
                       </a:r>
                       <a:endParaRPr lang="en-US" sz="1200" dirty="0"/>
                     </a:p>
@@ -4500,7 +4443,7 @@
                             <a:schemeClr val="tx2"/>
                           </a:solidFill>
                         </a:rPr>
-                        <a:t>15,40 – 16,93</a:t>
+                        <a:t>16,93%</a:t>
                       </a:r>
                       <a:endParaRPr lang="en-US" sz="1200" dirty="0"/>
                     </a:p>
@@ -4548,7 +4491,7 @@
                   </a:tcPr>
                 </a:tc>
               </a:tr>
-              <a:tr h="292608">
+              <a:tr h="347472">
                 <a:tc>
                   <a:txBody>
                     <a:bodyPr/>
@@ -4624,7 +4567,7 @@
                             <a:schemeClr val="tx1"/>
                           </a:solidFill>
                         </a:rPr>
-                        <a:t>+0,15 pp/mês</a:t>
+                        <a:t>subindo</a:t>
                       </a:r>
                       <a:endParaRPr lang="en-US" sz="1200" dirty="0"/>
                     </a:p>
@@ -4685,7 +4628,7 @@
                             <a:schemeClr val="tx2"/>
                           </a:solidFill>
                         </a:rPr>
-                        <a:t>−0,35 pp/mês</a:t>
+                        <a:t>caindo</a:t>
                       </a:r>
                       <a:endParaRPr lang="en-US" sz="1200" dirty="0"/>
                     </a:p>
@@ -4739,26 +4682,26 @@
       </p:graphicFrame>
       <p:sp>
         <p:nvSpPr>
-          <p:cNvPr id="8" name="Teste 1"/>
+          <p:cNvPr id="11" name="Painel leitura"/>
           <p:cNvSpPr/>
           <p:nvPr/>
         </p:nvSpPr>
         <p:spPr>
           <a:xfrm>
-            <a:off x="7863840" y="3611880"/>
-            <a:ext cx="3776472" cy="640080"/>
+            <a:off x="8366760" y="3657600"/>
+            <a:ext cx="3273552" cy="2148840"/>
           </a:xfrm>
           <a:prstGeom prst="roundRect">
             <a:avLst>
-              <a:gd name="adj" fmla="val 8571"/>
+              <a:gd name="adj" fmla="val 3404"/>
             </a:avLst>
           </a:prstGeom>
           <a:solidFill>
-            <a:schemeClr val="bg2"/>
+            <a:schemeClr val="tx2"/>
           </a:solidFill>
           <a:ln w="12700">
             <a:solidFill>
-              <a:schemeClr val="bg2"/>
+              <a:schemeClr val="tx2"/>
             </a:solidFill>
             <a:prstDash val="solid"/>
           </a:ln>
@@ -4766,39 +4709,14 @@
       </p:sp>
       <p:sp>
         <p:nvSpPr>
-          <p:cNvPr id="9" name="Marcador teste 1"/>
-          <p:cNvSpPr/>
-          <p:nvPr/>
-        </p:nvSpPr>
-        <p:spPr>
-          <a:xfrm>
-            <a:off x="7991856" y="3803904"/>
-            <a:ext cx="256032" cy="256032"/>
-          </a:xfrm>
-          <a:prstGeom prst="ellipse">
-            <a:avLst/>
-          </a:prstGeom>
-          <a:solidFill>
-            <a:schemeClr val="accent2"/>
-          </a:solidFill>
-          <a:ln w="12700">
-            <a:solidFill>
-              <a:schemeClr val="accent2"/>
-            </a:solidFill>
-            <a:prstDash val="solid"/>
-          </a:ln>
-        </p:spPr>
-      </p:sp>
-      <p:sp>
-        <p:nvSpPr>
-          <p:cNvPr id="10" name="Texto teste 1"/>
+          <p:cNvPr id="12" name="Chapéu leitura"/>
           <p:cNvSpPr txBox="1"/>
           <p:nvPr/>
         </p:nvSpPr>
         <p:spPr>
           <a:xfrm>
-            <a:off x="8366760" y="3666744"/>
-            <a:ext cx="3182112" cy="548640"/>
+            <a:off x="8595360" y="3840480"/>
+            <a:ext cx="2816352" cy="274320"/>
           </a:xfrm>
           <a:prstGeom prst="rect">
             <a:avLst/>
@@ -4814,301 +4732,70 @@
               <a:buNone/>
             </a:pPr>
             <a:r>
-              <a:rPr lang="en-US" sz="1300" b="1" dirty="0">
-                <a:solidFill>
-                  <a:schemeClr val="tx1"/>
+              <a:rPr lang="en-US" sz="1100" b="1" spc="200" kern="0" dirty="0">
+                <a:solidFill>
+                  <a:schemeClr val="accent2"/>
                 </a:solidFill>
               </a:rPr>
-              <a:t>Mann-Whitney (unilateral)  </a:t>
-            </a:r>
+              <a:t>O QUE O GRÁFICO MOSTRA</a:t>
+            </a:r>
+            <a:endParaRPr lang="en-US" sz="1100" dirty="0"/>
+          </a:p>
+        </p:txBody>
+      </p:sp>
+      <p:sp>
+        <p:nvSpPr>
+          <p:cNvPr id="13" name="Texto leitura"/>
+          <p:cNvSpPr txBox="1"/>
+          <p:nvPr/>
+        </p:nvSpPr>
+        <p:spPr>
+          <a:xfrm>
+            <a:off x="8595360" y="4206240"/>
+            <a:ext cx="2816352" cy="1463040"/>
+          </a:xfrm>
+          <a:prstGeom prst="rect">
+            <a:avLst/>
+          </a:prstGeom>
+          <a:noFill/>
+          <a:ln/>
+        </p:spPr>
+        <p:txBody>
+          <a:bodyPr wrap="square" lIns="0" tIns="0" rIns="0" bIns="0" rtlCol="0" anchor="t"/>
+          <a:lstStyle/>
+          <a:p>
             <a:pPr indent="0" marL="0">
+              <a:spcAft>
+                <a:spcPts val="800"/>
+              </a:spcAft>
               <a:buNone/>
             </a:pPr>
             <a:r>
-              <a:rPr lang="en-US" sz="1300" b="1" dirty="0">
-                <a:solidFill>
-                  <a:schemeClr val="tx2"/>
+              <a:rPr lang="en-US" sz="1400" dirty="0">
+                <a:solidFill>
+                  <a:schemeClr val="bg1"/>
                 </a:solidFill>
               </a:rPr>
-              <a:t>p = 0,024</a:t>
-            </a:r>
-            <a:endParaRPr lang="en-US" sz="1300" dirty="0"/>
+              <a:t>Com a rotina, todos os meses ficaram abaixo da média anterior.</a:t>
+            </a:r>
+            <a:endParaRPr lang="en-US" sz="1400" dirty="0"/>
           </a:p>
           <a:p>
             <a:pPr indent="0" marL="0">
+              <a:spcAft>
+                <a:spcPts val="800"/>
+              </a:spcAft>
               <a:buNone/>
             </a:pPr>
             <a:r>
-              <a:rPr lang="en-US" sz="1100" dirty="0">
-                <a:solidFill>
-                  <a:schemeClr val="accent5"/>
+              <a:rPr lang="en-US" sz="1400" b="1" dirty="0">
+                <a:solidFill>
+                  <a:schemeClr val="accent2"/>
                 </a:solidFill>
               </a:rPr>
-              <a:t>queda significativa a 95% de confiança</a:t>
-            </a:r>
-            <a:endParaRPr lang="en-US" sz="1300" dirty="0"/>
-          </a:p>
-        </p:txBody>
-      </p:sp>
-      <p:sp>
-        <p:nvSpPr>
-          <p:cNvPr id="11" name="Teste 2"/>
-          <p:cNvSpPr/>
-          <p:nvPr/>
-        </p:nvSpPr>
-        <p:spPr>
-          <a:xfrm>
-            <a:off x="7863840" y="4361688"/>
-            <a:ext cx="3776472" cy="640080"/>
-          </a:xfrm>
-          <a:prstGeom prst="roundRect">
-            <a:avLst>
-              <a:gd name="adj" fmla="val 8571"/>
-            </a:avLst>
-          </a:prstGeom>
-          <a:solidFill>
-            <a:schemeClr val="bg2"/>
-          </a:solidFill>
-          <a:ln w="12700">
-            <a:solidFill>
-              <a:schemeClr val="bg2"/>
-            </a:solidFill>
-            <a:prstDash val="solid"/>
-          </a:ln>
-        </p:spPr>
-      </p:sp>
-      <p:sp>
-        <p:nvSpPr>
-          <p:cNvPr id="12" name="Marcador teste 2"/>
-          <p:cNvSpPr/>
-          <p:nvPr/>
-        </p:nvSpPr>
-        <p:spPr>
-          <a:xfrm>
-            <a:off x="7991856" y="4553712"/>
-            <a:ext cx="256032" cy="256032"/>
-          </a:xfrm>
-          <a:prstGeom prst="ellipse">
-            <a:avLst/>
-          </a:prstGeom>
-          <a:solidFill>
-            <a:schemeClr val="accent6"/>
-          </a:solidFill>
-          <a:ln w="12700">
-            <a:solidFill>
-              <a:schemeClr val="accent6"/>
-            </a:solidFill>
-            <a:prstDash val="solid"/>
-          </a:ln>
-        </p:spPr>
-      </p:sp>
-      <p:sp>
-        <p:nvSpPr>
-          <p:cNvPr id="13" name="Texto teste 2"/>
-          <p:cNvSpPr txBox="1"/>
-          <p:nvPr/>
-        </p:nvSpPr>
-        <p:spPr>
-          <a:xfrm>
-            <a:off x="8366760" y="4416552"/>
-            <a:ext cx="3182112" cy="548640"/>
-          </a:xfrm>
-          <a:prstGeom prst="rect">
-            <a:avLst/>
-          </a:prstGeom>
-          <a:noFill/>
-          <a:ln/>
-        </p:spPr>
-        <p:txBody>
-          <a:bodyPr wrap="square" lIns="0" tIns="0" rIns="0" bIns="0" rtlCol="0" anchor="ctr"/>
-          <a:lstStyle/>
-          <a:p>
-            <a:pPr indent="0" marL="0">
-              <a:buNone/>
-            </a:pPr>
-            <a:r>
-              <a:rPr lang="en-US" sz="1300" b="1" dirty="0">
-                <a:solidFill>
-                  <a:schemeClr val="tx1"/>
-                </a:solidFill>
-              </a:rPr>
-              <a:t>t de Welch  </a:t>
-            </a:r>
-            <a:pPr indent="0" marL="0">
-              <a:buNone/>
-            </a:pPr>
-            <a:r>
-              <a:rPr lang="en-US" sz="1300" b="1" dirty="0">
-                <a:solidFill>
-                  <a:schemeClr val="tx2"/>
-                </a:solidFill>
-              </a:rPr>
-              <a:t>p = 0,056</a:t>
-            </a:r>
-            <a:endParaRPr lang="en-US" sz="1300" dirty="0"/>
-          </a:p>
-          <a:p>
-            <a:pPr indent="0" marL="0">
-              <a:buNone/>
-            </a:pPr>
-            <a:r>
-              <a:rPr lang="en-US" sz="1100" dirty="0">
-                <a:solidFill>
-                  <a:schemeClr val="accent5"/>
-                </a:solidFill>
-              </a:rPr>
-              <a:t>p = 0,026 contra a base jan–mai/26</a:t>
-            </a:r>
-            <a:endParaRPr lang="en-US" sz="1300" dirty="0"/>
-          </a:p>
-        </p:txBody>
-      </p:sp>
-      <p:sp>
-        <p:nvSpPr>
-          <p:cNvPr id="14" name="Teste 3"/>
-          <p:cNvSpPr/>
-          <p:nvPr/>
-        </p:nvSpPr>
-        <p:spPr>
-          <a:xfrm>
-            <a:off x="7863840" y="5111496"/>
-            <a:ext cx="3776472" cy="640080"/>
-          </a:xfrm>
-          <a:prstGeom prst="roundRect">
-            <a:avLst>
-              <a:gd name="adj" fmla="val 8571"/>
-            </a:avLst>
-          </a:prstGeom>
-          <a:solidFill>
-            <a:schemeClr val="bg2"/>
-          </a:solidFill>
-          <a:ln w="12700">
-            <a:solidFill>
-              <a:schemeClr val="bg2"/>
-            </a:solidFill>
-            <a:prstDash val="solid"/>
-          </a:ln>
-        </p:spPr>
-      </p:sp>
-      <p:sp>
-        <p:nvSpPr>
-          <p:cNvPr id="15" name="Marcador teste 3"/>
-          <p:cNvSpPr/>
-          <p:nvPr/>
-        </p:nvSpPr>
-        <p:spPr>
-          <a:xfrm>
-            <a:off x="7991856" y="5303520"/>
-            <a:ext cx="256032" cy="256032"/>
-          </a:xfrm>
-          <a:prstGeom prst="ellipse">
-            <a:avLst/>
-          </a:prstGeom>
-          <a:solidFill>
-            <a:schemeClr val="accent2"/>
-          </a:solidFill>
-          <a:ln w="12700">
-            <a:solidFill>
-              <a:schemeClr val="accent2"/>
-            </a:solidFill>
-            <a:prstDash val="solid"/>
-          </a:ln>
-        </p:spPr>
-      </p:sp>
-      <p:sp>
-        <p:nvSpPr>
-          <p:cNvPr id="16" name="Texto teste 3"/>
-          <p:cNvSpPr txBox="1"/>
-          <p:nvPr/>
-        </p:nvSpPr>
-        <p:spPr>
-          <a:xfrm>
-            <a:off x="8366760" y="5166360"/>
-            <a:ext cx="3182112" cy="548640"/>
-          </a:xfrm>
-          <a:prstGeom prst="rect">
-            <a:avLst/>
-          </a:prstGeom>
-          <a:noFill/>
-          <a:ln/>
-        </p:spPr>
-        <p:txBody>
-          <a:bodyPr wrap="square" lIns="0" tIns="0" rIns="0" bIns="0" rtlCol="0" anchor="ctr"/>
-          <a:lstStyle/>
-          <a:p>
-            <a:pPr indent="0" marL="0">
-              <a:buNone/>
-            </a:pPr>
-            <a:r>
-              <a:rPr lang="en-US" sz="1300" b="1" dirty="0">
-                <a:solidFill>
-                  <a:schemeClr val="tx1"/>
-                </a:solidFill>
-              </a:rPr>
-              <a:t>Regras da carta de controle  </a:t>
-            </a:r>
-            <a:pPr indent="0" marL="0">
-              <a:buNone/>
-            </a:pPr>
-            <a:r>
-              <a:rPr lang="en-US" sz="1300" b="1" dirty="0">
-                <a:solidFill>
-                  <a:schemeClr val="tx2"/>
-                </a:solidFill>
-              </a:rPr>
-              <a:t>violadas</a:t>
-            </a:r>
-            <a:endParaRPr lang="en-US" sz="1300" dirty="0"/>
-          </a:p>
-          <a:p>
-            <a:pPr indent="0" marL="0">
-              <a:buNone/>
-            </a:pPr>
-            <a:r>
-              <a:rPr lang="en-US" sz="1100" dirty="0">
-                <a:solidFill>
-                  <a:schemeClr val="accent5"/>
-                </a:solidFill>
-              </a:rPr>
-              <a:t>4 de 5 meses abaixo de −1σ; set e out abaixo do LIC</a:t>
-            </a:r>
-            <a:endParaRPr lang="en-US" sz="1300" dirty="0"/>
-          </a:p>
-        </p:txBody>
-      </p:sp>
-      <p:sp>
-        <p:nvSpPr>
-          <p:cNvPr id="17" name="Nota metodológica"/>
-          <p:cNvSpPr txBox="1"/>
-          <p:nvPr/>
-        </p:nvSpPr>
-        <p:spPr>
-          <a:xfrm>
-            <a:off x="548640" y="5943600"/>
-            <a:ext cx="11064240" cy="274320"/>
-          </a:xfrm>
-          <a:prstGeom prst="rect">
-            <a:avLst/>
-          </a:prstGeom>
-          <a:noFill/>
-          <a:ln/>
-        </p:spPr>
-        <p:txBody>
-          <a:bodyPr wrap="square" lIns="0" tIns="0" rIns="0" bIns="0" rtlCol="0" anchor="ctr"/>
-          <a:lstStyle/>
-          <a:p>
-            <a:pPr indent="0" marL="0">
-              <a:buNone/>
-            </a:pPr>
-            <a:r>
-              <a:rPr lang="en-US" sz="1000" dirty="0">
-                <a:solidFill>
-                  <a:schemeClr val="accent5"/>
-                </a:solidFill>
-              </a:rPr>
-              <a:t>LC, LSC e LIC calculados com a variação diária de nov/25–mai/26 (σ por amplitude móvel = 0,82 pp; n ≈ 30 dias por mês). Out/26 parcial (1 a 22/10).</a:t>
-            </a:r>
-            <a:endParaRPr lang="en-US" sz="1000" dirty="0"/>
+              <a:t>Julho, setembro e outubro ficaram abaixo do limite inferior: a queda não é variação normal do processo.</a:t>
+            </a:r>
+            <a:endParaRPr lang="en-US" sz="1400" dirty="0"/>
           </a:p>
         </p:txBody>
       </p:sp>
@@ -5215,7 +4902,7 @@
                 <a:ea typeface="Calibri" pitchFamily="34" charset="-122"/>
                 <a:cs typeface="Calibri" pitchFamily="34" charset="-120"/>
               </a:rPr>
-              <a:t>Uma rotina simples gerou o ganho; agora é cumpri-la 100%</a:t>
+              <a:t>A rota de limpeza implantada gerou a redução da umidade</a:t>
             </a:r>
             <a:endParaRPr lang="en-US" sz="2600" dirty="0"/>
           </a:p>
@@ -5223,7 +4910,7 @@
       </p:sp>
       <p:sp>
         <p:nvSpPr>
-          <p:cNvPr id="3" name="Painel o que mudou"/>
+          <p:cNvPr id="3" name="Painel o que foi implantado"/>
           <p:cNvSpPr/>
           <p:nvPr/>
         </p:nvSpPr>
@@ -5250,7 +4937,7 @@
       </p:sp>
       <p:sp>
         <p:nvSpPr>
-          <p:cNvPr id="4" name="Chapéu o que mudou"/>
+          <p:cNvPr id="4" name="Chapéu implantado"/>
           <p:cNvSpPr txBox="1"/>
           <p:nvPr/>
         </p:nvSpPr>
@@ -5278,7 +4965,7 @@
                   <a:schemeClr val="accent2"/>
                 </a:solidFill>
               </a:rPr>
-              <a:t>O QUE MUDOU A PARTIR DE JUN/26</a:t>
+              <a:t>O QUE FOI IMPLANTADO EM JUN/26</a:t>
             </a:r>
             <a:endParaRPr lang="en-US" sz="1200" dirty="0"/>
           </a:p>
@@ -5338,7 +5025,7 @@
                   <a:schemeClr val="bg1"/>
                 </a:solidFill>
               </a:rPr>
-              <a:t>Rota fixa: um filtro por dia útil</a:t>
+              <a:t>Rota fixa de limpeza</a:t>
             </a:r>
             <a:endParaRPr lang="en-US" sz="1500" dirty="0"/>
           </a:p>
@@ -5352,7 +5039,7 @@
                   <a:schemeClr val="accent6"/>
                 </a:solidFill>
               </a:rPr>
-              <a:t>Sequência respeitada toda semana</a:t>
+              <a:t>Um filtro por dia útil, sempre na mesma sequência</a:t>
             </a:r>
             <a:endParaRPr lang="en-US" sz="1500" dirty="0"/>
           </a:p>
@@ -5412,7 +5099,7 @@
                   <a:schemeClr val="bg1"/>
                 </a:solidFill>
               </a:rPr>
-              <a:t>Dono definido para cada limpeza</a:t>
+              <a:t>Responsável em cada turno</a:t>
             </a:r>
             <a:endParaRPr lang="en-US" sz="1500" dirty="0"/>
           </a:p>
@@ -5426,7 +5113,7 @@
                   <a:schemeClr val="accent6"/>
                 </a:solidFill>
               </a:rPr>
-              <a:t>Letra no turno 1 (07–19h), pela escala de revezamento</a:t>
+              <a:t>Limpeza feita pela turma do dia, conforme a escala</a:t>
             </a:r>
             <a:endParaRPr lang="en-US" sz="1500" dirty="0"/>
           </a:p>
@@ -5486,7 +5173,7 @@
                   <a:schemeClr val="bg1"/>
                 </a:solidFill>
               </a:rPr>
-              <a:t>Gestão mensal da aderência</a:t>
+              <a:t>Todos os 5 filtros, toda semana</a:t>
             </a:r>
             <a:endParaRPr lang="en-US" sz="1500" dirty="0"/>
           </a:p>
@@ -5500,7 +5187,7 @@
                   <a:schemeClr val="accent6"/>
                 </a:solidFill>
               </a:rPr>
-              <a:t>Previstas × realizadas por letra e por operador</a:t>
+              <a:t>Nenhum filtro fica mais de uma semana sem limpeza</a:t>
             </a:r>
             <a:endParaRPr lang="en-US" sz="1500" dirty="0"/>
           </a:p>
@@ -6079,7 +5766,7 @@
         </p:nvSpPr>
         <p:spPr>
           <a:xfrm>
-            <a:off x="8686800" y="1984248"/>
+            <a:off x="8686800" y="2029968"/>
             <a:ext cx="329184" cy="329184"/>
           </a:xfrm>
           <a:prstGeom prst="ellipse">
@@ -6104,7 +5791,7 @@
         </p:nvSpPr>
         <p:spPr>
           <a:xfrm>
-            <a:off x="8686800" y="1984248"/>
+            <a:off x="8686800" y="2029968"/>
             <a:ext cx="329184" cy="329184"/>
           </a:xfrm>
           <a:prstGeom prst="rect">
@@ -6140,7 +5827,7 @@
         </p:nvSpPr>
         <p:spPr>
           <a:xfrm>
-            <a:off x="9144000" y="1965960"/>
+            <a:off x="9144000" y="2011680"/>
             <a:ext cx="2496312" cy="822960"/>
           </a:xfrm>
           <a:prstGeom prst="rect">
@@ -6162,7 +5849,7 @@
                   <a:schemeClr val="tx1"/>
                 </a:solidFill>
               </a:rPr>
-              <a:t>Aderência à rota ≥ 90%</a:t>
+              <a:t>Manter a rota como padrão</a:t>
             </a:r>
             <a:endParaRPr lang="en-US" sz="1400" dirty="0"/>
           </a:p>
@@ -6176,7 +5863,7 @@
                   <a:schemeClr val="accent5"/>
                 </a:solidFill>
               </a:rPr>
-              <a:t>Hoje: set/26 41%; out/26 67% (até 22/10)</a:t>
+              <a:t>Incluir em procedimento operacional</a:t>
             </a:r>
             <a:endParaRPr lang="en-US" sz="1400" dirty="0"/>
           </a:p>
@@ -6190,7 +5877,7 @@
         </p:nvSpPr>
         <p:spPr>
           <a:xfrm>
-            <a:off x="8686800" y="2944368"/>
+            <a:off x="8686800" y="3081528"/>
             <a:ext cx="329184" cy="329184"/>
           </a:xfrm>
           <a:prstGeom prst="ellipse">
@@ -6215,7 +5902,7 @@
         </p:nvSpPr>
         <p:spPr>
           <a:xfrm>
-            <a:off x="8686800" y="2944368"/>
+            <a:off x="8686800" y="3081528"/>
             <a:ext cx="329184" cy="329184"/>
           </a:xfrm>
           <a:prstGeom prst="rect">
@@ -6251,7 +5938,7 @@
         </p:nvSpPr>
         <p:spPr>
           <a:xfrm>
-            <a:off x="9144000" y="2926080"/>
+            <a:off x="9144000" y="3063240"/>
             <a:ext cx="2496312" cy="822960"/>
           </a:xfrm>
           <a:prstGeom prst="rect">
@@ -6273,7 +5960,7 @@
                   <a:schemeClr val="tx1"/>
                 </a:solidFill>
               </a:rPr>
-              <a:t>Umidade × aderência todo mês</a:t>
+              <a:t>Acompanhar a umidade mensal</a:t>
             </a:r>
             <a:endParaRPr lang="en-US" sz="1400" dirty="0"/>
           </a:p>
@@ -6287,7 +5974,7 @@
                   <a:schemeClr val="accent5"/>
                 </a:solidFill>
               </a:rPr>
-              <a:t>Fechamento no painel de limpeza</a:t>
+              <a:t>Confirmar o novo patamar</a:t>
             </a:r>
             <a:endParaRPr lang="en-US" sz="1400" dirty="0"/>
           </a:p>
@@ -6301,7 +5988,7 @@
         </p:nvSpPr>
         <p:spPr>
           <a:xfrm>
-            <a:off x="8686800" y="3904488"/>
+            <a:off x="8686800" y="4133088"/>
             <a:ext cx="329184" cy="329184"/>
           </a:xfrm>
           <a:prstGeom prst="ellipse">
@@ -6326,7 +6013,7 @@
         </p:nvSpPr>
         <p:spPr>
           <a:xfrm>
-            <a:off x="8686800" y="3904488"/>
+            <a:off x="8686800" y="4133088"/>
             <a:ext cx="329184" cy="329184"/>
           </a:xfrm>
           <a:prstGeom prst="rect">
@@ -6362,7 +6049,7 @@
         </p:nvSpPr>
         <p:spPr>
           <a:xfrm>
-            <a:off x="9144000" y="3886200"/>
+            <a:off x="9144000" y="4114800"/>
             <a:ext cx="2496312" cy="822960"/>
           </a:xfrm>
           <a:prstGeom prst="rect">
@@ -6398,156 +6085,9 @@
                   <a:schemeClr val="accent5"/>
                 </a:solidFill>
               </a:rPr>
-              <a:t>−25 kg de água/t seca × produção = energia no forno</a:t>
+              <a:t>Menos água na torta = menos energia no forno</a:t>
             </a:r>
             <a:endParaRPr lang="en-US" sz="1400" dirty="0"/>
-          </a:p>
-        </p:txBody>
-      </p:sp>
-      <p:sp>
-        <p:nvSpPr>
-          <p:cNvPr id="36" name="Número passo 4"/>
-          <p:cNvSpPr/>
-          <p:nvPr/>
-        </p:nvSpPr>
-        <p:spPr>
-          <a:xfrm>
-            <a:off x="8686800" y="4864608"/>
-            <a:ext cx="329184" cy="329184"/>
-          </a:xfrm>
-          <a:prstGeom prst="ellipse">
-            <a:avLst/>
-          </a:prstGeom>
-          <a:solidFill>
-            <a:schemeClr val="accent2"/>
-          </a:solidFill>
-          <a:ln w="12700">
-            <a:solidFill>
-              <a:schemeClr val="accent2"/>
-            </a:solidFill>
-            <a:prstDash val="solid"/>
-          </a:ln>
-        </p:spPr>
-      </p:sp>
-      <p:sp>
-        <p:nvSpPr>
-          <p:cNvPr id="37" name="Texto número 4"/>
-          <p:cNvSpPr txBox="1"/>
-          <p:nvPr/>
-        </p:nvSpPr>
-        <p:spPr>
-          <a:xfrm>
-            <a:off x="8686800" y="4864608"/>
-            <a:ext cx="329184" cy="329184"/>
-          </a:xfrm>
-          <a:prstGeom prst="rect">
-            <a:avLst/>
-          </a:prstGeom>
-          <a:noFill/>
-          <a:ln/>
-        </p:spPr>
-        <p:txBody>
-          <a:bodyPr wrap="square" lIns="0" tIns="0" rIns="0" bIns="0" rtlCol="0" anchor="ctr"/>
-          <a:lstStyle/>
-          <a:p>
-            <a:pPr algn="ctr" indent="0" marL="0">
-              <a:buNone/>
-            </a:pPr>
-            <a:r>
-              <a:rPr lang="en-US" sz="1300" b="1" dirty="0">
-                <a:solidFill>
-                  <a:schemeClr val="tx2"/>
-                </a:solidFill>
-              </a:rPr>
-              <a:t>4</a:t>
-            </a:r>
-            <a:endParaRPr lang="en-US" sz="1300" dirty="0"/>
-          </a:p>
-        </p:txBody>
-      </p:sp>
-      <p:sp>
-        <p:nvSpPr>
-          <p:cNvPr id="38" name="Texto passo 4"/>
-          <p:cNvSpPr txBox="1"/>
-          <p:nvPr/>
-        </p:nvSpPr>
-        <p:spPr>
-          <a:xfrm>
-            <a:off x="9144000" y="4846320"/>
-            <a:ext cx="2496312" cy="822960"/>
-          </a:xfrm>
-          <a:prstGeom prst="rect">
-            <a:avLst/>
-          </a:prstGeom>
-          <a:noFill/>
-          <a:ln/>
-        </p:spPr>
-        <p:txBody>
-          <a:bodyPr wrap="square" lIns="0" tIns="0" rIns="0" bIns="0" rtlCol="0" anchor="t"/>
-          <a:lstStyle/>
-          <a:p>
-            <a:pPr indent="0" marL="0">
-              <a:buNone/>
-            </a:pPr>
-            <a:r>
-              <a:rPr lang="en-US" sz="1400" b="1" dirty="0">
-                <a:solidFill>
-                  <a:schemeClr val="tx1"/>
-                </a:solidFill>
-              </a:rPr>
-              <a:t>Padronizar em procedimento</a:t>
-            </a:r>
-            <a:endParaRPr lang="en-US" sz="1400" dirty="0"/>
-          </a:p>
-          <a:p>
-            <a:pPr indent="0" marL="0">
-              <a:buNone/>
-            </a:pPr>
-            <a:r>
-              <a:rPr lang="en-US" sz="1200" dirty="0">
-                <a:solidFill>
-                  <a:schemeClr val="accent5"/>
-                </a:solidFill>
-              </a:rPr>
-              <a:t>Rota, responsáveis e checklist da limpeza</a:t>
-            </a:r>
-            <a:endParaRPr lang="en-US" sz="1400" dirty="0"/>
-          </a:p>
-        </p:txBody>
-      </p:sp>
-      <p:sp>
-        <p:nvSpPr>
-          <p:cNvPr id="39" name="Limitações"/>
-          <p:cNvSpPr txBox="1"/>
-          <p:nvPr/>
-        </p:nvSpPr>
-        <p:spPr>
-          <a:xfrm>
-            <a:off x="548640" y="5943600"/>
-            <a:ext cx="11064240" cy="274320"/>
-          </a:xfrm>
-          <a:prstGeom prst="rect">
-            <a:avLst/>
-          </a:prstGeom>
-          <a:noFill/>
-          <a:ln/>
-        </p:spPr>
-        <p:txBody>
-          <a:bodyPr wrap="square" lIns="0" tIns="0" rIns="0" bIns="0" rtlCol="0" anchor="ctr"/>
-          <a:lstStyle/>
-          <a:p>
-            <a:pPr indent="0" marL="0">
-              <a:buNone/>
-            </a:pPr>
-            <a:r>
-              <a:rPr lang="en-US" sz="1000" dirty="0">
-                <a:solidFill>
-                  <a:schemeClr val="accent5"/>
-                </a:solidFill>
-              </a:rPr>
-              <a:t>Limitações: a troca geral dos tecidos do FP001 (01/08/26) também contribui para o resultado; out/26 é parcial; alimentação, granulometria e pressão de filtragem não foram isoladas nesta análise.</a:t>
-            </a:r>
-            <a:endParaRPr lang="en-US" sz="1000" dirty="0"/>
           </a:p>
         </p:txBody>
       </p:sp>

</xml_diff>